<commit_message>
Update project review deck with logo branding
</commit_message>
<xml_diff>
--- a/Fable-Fur-Review.pptx
+++ b/Fable-Fur-Review.pptx
@@ -3356,6 +3356,80 @@
           </a:p>
         </p:txBody>
       </p:sp>
+      <p:pic>
+        <p:nvPicPr>
+          <p:cNvPr id="6" name="Picture 5" descr="logo.png"/>
+          <p:cNvPicPr>
+            <a:picLocks noChangeAspect="1"/>
+          </p:cNvPicPr>
+          <p:nvPr/>
+        </p:nvPicPr>
+        <p:blipFill>
+          <a:blip r:embed="rId2"/>
+          <a:stretch>
+            <a:fillRect/>
+          </a:stretch>
+        </p:blipFill>
+        <p:spPr>
+          <a:xfrm>
+            <a:off x="10789920" y="320040"/>
+            <a:ext cx="822960" cy="822960"/>
+          </a:xfrm>
+          <a:prstGeom prst="rect">
+            <a:avLst/>
+          </a:prstGeom>
+        </p:spPr>
+      </p:pic>
+      <p:sp>
+        <p:nvSpPr>
+          <p:cNvPr id="7" name="Rectangle 6"/>
+          <p:cNvSpPr/>
+          <p:nvPr/>
+        </p:nvSpPr>
+        <p:spPr>
+          <a:xfrm>
+            <a:off x="640080" y="182880"/>
+            <a:ext cx="2011680" cy="640080"/>
+          </a:xfrm>
+          <a:prstGeom prst="rect">
+            <a:avLst/>
+          </a:prstGeom>
+          <a:noFill/>
+          <a:ln>
+            <a:noFill/>
+          </a:ln>
+        </p:spPr>
+        <p:style>
+          <a:lnRef idx="1">
+            <a:schemeClr val="accent1"/>
+          </a:lnRef>
+          <a:fillRef idx="3">
+            <a:schemeClr val="accent1"/>
+          </a:fillRef>
+          <a:effectRef idx="2">
+            <a:schemeClr val="accent1"/>
+          </a:effectRef>
+          <a:fontRef idx="minor">
+            <a:schemeClr val="lt1"/>
+          </a:fontRef>
+        </p:style>
+        <p:txBody>
+          <a:bodyPr rtlCol="0" anchor="ctr"/>
+          <a:lstStyle/>
+          <a:p>
+            <a:pPr algn="ctr">
+              <a:defRPr sz="2400" b="1">
+                <a:solidFill>
+                  <a:srgbClr val="121F35"/>
+                </a:solidFill>
+              </a:defRPr>
+            </a:pPr>
+            <a:r>
+              <a:t>Fable &amp; Fur</a:t>
+            </a:r>
+          </a:p>
+        </p:txBody>
+      </p:sp>
     </p:spTree>
   </p:cSld>
   <p:clrMapOvr>
@@ -3686,6 +3760,30 @@
           </a:p>
         </p:txBody>
       </p:sp>
+      <p:pic>
+        <p:nvPicPr>
+          <p:cNvPr id="7" name="Picture 6" descr="logo.png"/>
+          <p:cNvPicPr>
+            <a:picLocks noChangeAspect="1"/>
+          </p:cNvPicPr>
+          <p:nvPr/>
+        </p:nvPicPr>
+        <p:blipFill>
+          <a:blip r:embed="rId2"/>
+          <a:stretch>
+            <a:fillRect/>
+          </a:stretch>
+        </p:blipFill>
+        <p:spPr>
+          <a:xfrm>
+            <a:off x="10789920" y="320040"/>
+            <a:ext cx="822960" cy="822960"/>
+          </a:xfrm>
+          <a:prstGeom prst="rect">
+            <a:avLst/>
+          </a:prstGeom>
+        </p:spPr>
+      </p:pic>
     </p:spTree>
   </p:cSld>
   <p:clrMapOvr>
@@ -3914,6 +4012,30 @@
           </a:p>
         </p:txBody>
       </p:sp>
+      <p:pic>
+        <p:nvPicPr>
+          <p:cNvPr id="5" name="Picture 4" descr="logo.png"/>
+          <p:cNvPicPr>
+            <a:picLocks noChangeAspect="1"/>
+          </p:cNvPicPr>
+          <p:nvPr/>
+        </p:nvPicPr>
+        <p:blipFill>
+          <a:blip r:embed="rId2"/>
+          <a:stretch>
+            <a:fillRect/>
+          </a:stretch>
+        </p:blipFill>
+        <p:spPr>
+          <a:xfrm>
+            <a:off x="10789920" y="320040"/>
+            <a:ext cx="822960" cy="822960"/>
+          </a:xfrm>
+          <a:prstGeom prst="rect">
+            <a:avLst/>
+          </a:prstGeom>
+        </p:spPr>
+      </p:pic>
     </p:spTree>
   </p:cSld>
   <p:clrMapOvr>
@@ -4213,6 +4335,30 @@
           </a:p>
         </p:txBody>
       </p:sp>
+      <p:pic>
+        <p:nvPicPr>
+          <p:cNvPr id="8" name="Picture 7" descr="logo.png"/>
+          <p:cNvPicPr>
+            <a:picLocks noChangeAspect="1"/>
+          </p:cNvPicPr>
+          <p:nvPr/>
+        </p:nvPicPr>
+        <p:blipFill>
+          <a:blip r:embed="rId2"/>
+          <a:stretch>
+            <a:fillRect/>
+          </a:stretch>
+        </p:blipFill>
+        <p:spPr>
+          <a:xfrm>
+            <a:off x="10789920" y="320040"/>
+            <a:ext cx="822960" cy="822960"/>
+          </a:xfrm>
+          <a:prstGeom prst="rect">
+            <a:avLst/>
+          </a:prstGeom>
+        </p:spPr>
+      </p:pic>
     </p:spTree>
   </p:cSld>
   <p:clrMapOvr>
@@ -4639,6 +4785,30 @@
           </a:p>
         </p:txBody>
       </p:sp>
+      <p:pic>
+        <p:nvPicPr>
+          <p:cNvPr id="9" name="Picture 8" descr="logo.png"/>
+          <p:cNvPicPr>
+            <a:picLocks noChangeAspect="1"/>
+          </p:cNvPicPr>
+          <p:nvPr/>
+        </p:nvPicPr>
+        <p:blipFill>
+          <a:blip r:embed="rId2"/>
+          <a:stretch>
+            <a:fillRect/>
+          </a:stretch>
+        </p:blipFill>
+        <p:spPr>
+          <a:xfrm>
+            <a:off x="10789920" y="320040"/>
+            <a:ext cx="822960" cy="822960"/>
+          </a:xfrm>
+          <a:prstGeom prst="rect">
+            <a:avLst/>
+          </a:prstGeom>
+        </p:spPr>
+      </p:pic>
     </p:spTree>
   </p:cSld>
   <p:clrMapOvr>
@@ -4939,6 +5109,30 @@
           </a:p>
         </p:txBody>
       </p:sp>
+      <p:pic>
+        <p:nvPicPr>
+          <p:cNvPr id="6" name="Picture 5" descr="logo.png"/>
+          <p:cNvPicPr>
+            <a:picLocks noChangeAspect="1"/>
+          </p:cNvPicPr>
+          <p:nvPr/>
+        </p:nvPicPr>
+        <p:blipFill>
+          <a:blip r:embed="rId2"/>
+          <a:stretch>
+            <a:fillRect/>
+          </a:stretch>
+        </p:blipFill>
+        <p:spPr>
+          <a:xfrm>
+            <a:off x="10789920" y="320040"/>
+            <a:ext cx="822960" cy="822960"/>
+          </a:xfrm>
+          <a:prstGeom prst="rect">
+            <a:avLst/>
+          </a:prstGeom>
+        </p:spPr>
+      </p:pic>
     </p:spTree>
   </p:cSld>
   <p:clrMapOvr>
@@ -5041,6 +5235,30 @@
           </a:p>
         </p:txBody>
       </p:sp>
+      <p:pic>
+        <p:nvPicPr>
+          <p:cNvPr id="3" name="Picture 2" descr="logo.png"/>
+          <p:cNvPicPr>
+            <a:picLocks noChangeAspect="1"/>
+          </p:cNvPicPr>
+          <p:nvPr/>
+        </p:nvPicPr>
+        <p:blipFill>
+          <a:blip r:embed="rId2"/>
+          <a:stretch>
+            <a:fillRect/>
+          </a:stretch>
+        </p:blipFill>
+        <p:spPr>
+          <a:xfrm>
+            <a:off x="10789920" y="320040"/>
+            <a:ext cx="822960" cy="822960"/>
+          </a:xfrm>
+          <a:prstGeom prst="rect">
+            <a:avLst/>
+          </a:prstGeom>
+        </p:spPr>
+      </p:pic>
     </p:spTree>
   </p:cSld>
   <p:clrMapOvr>

</xml_diff>

<commit_message>
Fix PPT logo sizing
</commit_message>
<xml_diff>
--- a/Fable-Fur-Review.pptx
+++ b/Fable-Fur-Review.pptx
@@ -3356,9 +3356,59 @@
           </a:p>
         </p:txBody>
       </p:sp>
+      <p:sp>
+        <p:nvSpPr>
+          <p:cNvPr id="7" name="Rectangle 6"/>
+          <p:cNvSpPr/>
+          <p:nvPr/>
+        </p:nvSpPr>
+        <p:spPr>
+          <a:xfrm>
+            <a:off x="640080" y="182880"/>
+            <a:ext cx="2011680" cy="640080"/>
+          </a:xfrm>
+          <a:prstGeom prst="rect">
+            <a:avLst/>
+          </a:prstGeom>
+          <a:noFill/>
+          <a:ln>
+            <a:noFill/>
+          </a:ln>
+        </p:spPr>
+        <p:style>
+          <a:lnRef idx="1">
+            <a:schemeClr val="accent1"/>
+          </a:lnRef>
+          <a:fillRef idx="3">
+            <a:schemeClr val="accent1"/>
+          </a:fillRef>
+          <a:effectRef idx="2">
+            <a:schemeClr val="accent1"/>
+          </a:effectRef>
+          <a:fontRef idx="minor">
+            <a:schemeClr val="lt1"/>
+          </a:fontRef>
+        </p:style>
+        <p:txBody>
+          <a:bodyPr rtlCol="0" anchor="ctr"/>
+          <a:lstStyle/>
+          <a:p>
+            <a:pPr algn="ctr">
+              <a:defRPr sz="2400" b="1">
+                <a:solidFill>
+                  <a:srgbClr val="121F35"/>
+                </a:solidFill>
+              </a:defRPr>
+            </a:pPr>
+            <a:r>
+              <a:t>Fable &amp; Fur</a:t>
+            </a:r>
+          </a:p>
+        </p:txBody>
+      </p:sp>
       <p:pic>
         <p:nvPicPr>
-          <p:cNvPr id="6" name="Picture 5" descr="logo.png"/>
+          <p:cNvPr id="8" name="Picture 7" descr="image.png"/>
           <p:cNvPicPr>
             <a:picLocks noChangeAspect="1"/>
           </p:cNvPicPr>
@@ -3372,64 +3422,14 @@
         </p:blipFill>
         <p:spPr>
           <a:xfrm>
-            <a:off x="10789920" y="320040"/>
-            <a:ext cx="822960" cy="822960"/>
+            <a:off x="8961120" y="502920"/>
+            <a:ext cx="2103120" cy="1143000"/>
           </a:xfrm>
           <a:prstGeom prst="rect">
             <a:avLst/>
           </a:prstGeom>
         </p:spPr>
       </p:pic>
-      <p:sp>
-        <p:nvSpPr>
-          <p:cNvPr id="7" name="Rectangle 6"/>
-          <p:cNvSpPr/>
-          <p:nvPr/>
-        </p:nvSpPr>
-        <p:spPr>
-          <a:xfrm>
-            <a:off x="640080" y="182880"/>
-            <a:ext cx="2011680" cy="640080"/>
-          </a:xfrm>
-          <a:prstGeom prst="rect">
-            <a:avLst/>
-          </a:prstGeom>
-          <a:noFill/>
-          <a:ln>
-            <a:noFill/>
-          </a:ln>
-        </p:spPr>
-        <p:style>
-          <a:lnRef idx="1">
-            <a:schemeClr val="accent1"/>
-          </a:lnRef>
-          <a:fillRef idx="3">
-            <a:schemeClr val="accent1"/>
-          </a:fillRef>
-          <a:effectRef idx="2">
-            <a:schemeClr val="accent1"/>
-          </a:effectRef>
-          <a:fontRef idx="minor">
-            <a:schemeClr val="lt1"/>
-          </a:fontRef>
-        </p:style>
-        <p:txBody>
-          <a:bodyPr rtlCol="0" anchor="ctr"/>
-          <a:lstStyle/>
-          <a:p>
-            <a:pPr algn="ctr">
-              <a:defRPr sz="2400" b="1">
-                <a:solidFill>
-                  <a:srgbClr val="121F35"/>
-                </a:solidFill>
-              </a:defRPr>
-            </a:pPr>
-            <a:r>
-              <a:t>Fable &amp; Fur</a:t>
-            </a:r>
-          </a:p>
-        </p:txBody>
-      </p:sp>
     </p:spTree>
   </p:cSld>
   <p:clrMapOvr>
@@ -3762,7 +3762,7 @@
       </p:sp>
       <p:pic>
         <p:nvPicPr>
-          <p:cNvPr id="7" name="Picture 6" descr="logo.png"/>
+          <p:cNvPr id="7" name="Picture 6" descr="image.png"/>
           <p:cNvPicPr>
             <a:picLocks noChangeAspect="1"/>
           </p:cNvPicPr>
@@ -3776,8 +3776,8 @@
         </p:blipFill>
         <p:spPr>
           <a:xfrm>
-            <a:off x="10789920" y="320040"/>
-            <a:ext cx="822960" cy="822960"/>
+            <a:off x="11064240" y="182880"/>
+            <a:ext cx="822960" cy="457200"/>
           </a:xfrm>
           <a:prstGeom prst="rect">
             <a:avLst/>
@@ -4014,7 +4014,7 @@
       </p:sp>
       <p:pic>
         <p:nvPicPr>
-          <p:cNvPr id="5" name="Picture 4" descr="logo.png"/>
+          <p:cNvPr id="5" name="Picture 4" descr="image.png"/>
           <p:cNvPicPr>
             <a:picLocks noChangeAspect="1"/>
           </p:cNvPicPr>
@@ -4028,8 +4028,8 @@
         </p:blipFill>
         <p:spPr>
           <a:xfrm>
-            <a:off x="10789920" y="320040"/>
-            <a:ext cx="822960" cy="822960"/>
+            <a:off x="11064240" y="182880"/>
+            <a:ext cx="822960" cy="457200"/>
           </a:xfrm>
           <a:prstGeom prst="rect">
             <a:avLst/>
@@ -4337,7 +4337,7 @@
       </p:sp>
       <p:pic>
         <p:nvPicPr>
-          <p:cNvPr id="8" name="Picture 7" descr="logo.png"/>
+          <p:cNvPr id="8" name="Picture 7" descr="image.png"/>
           <p:cNvPicPr>
             <a:picLocks noChangeAspect="1"/>
           </p:cNvPicPr>
@@ -4351,8 +4351,8 @@
         </p:blipFill>
         <p:spPr>
           <a:xfrm>
-            <a:off x="10789920" y="320040"/>
-            <a:ext cx="822960" cy="822960"/>
+            <a:off x="11064240" y="182880"/>
+            <a:ext cx="822960" cy="457200"/>
           </a:xfrm>
           <a:prstGeom prst="rect">
             <a:avLst/>
@@ -4787,7 +4787,7 @@
       </p:sp>
       <p:pic>
         <p:nvPicPr>
-          <p:cNvPr id="9" name="Picture 8" descr="logo.png"/>
+          <p:cNvPr id="9" name="Picture 8" descr="image.png"/>
           <p:cNvPicPr>
             <a:picLocks noChangeAspect="1"/>
           </p:cNvPicPr>
@@ -4801,8 +4801,8 @@
         </p:blipFill>
         <p:spPr>
           <a:xfrm>
-            <a:off x="10789920" y="320040"/>
-            <a:ext cx="822960" cy="822960"/>
+            <a:off x="11064240" y="182880"/>
+            <a:ext cx="822960" cy="457200"/>
           </a:xfrm>
           <a:prstGeom prst="rect">
             <a:avLst/>
@@ -5111,7 +5111,7 @@
       </p:sp>
       <p:pic>
         <p:nvPicPr>
-          <p:cNvPr id="6" name="Picture 5" descr="logo.png"/>
+          <p:cNvPr id="6" name="Picture 5" descr="image.png"/>
           <p:cNvPicPr>
             <a:picLocks noChangeAspect="1"/>
           </p:cNvPicPr>
@@ -5125,8 +5125,8 @@
         </p:blipFill>
         <p:spPr>
           <a:xfrm>
-            <a:off x="10789920" y="320040"/>
-            <a:ext cx="822960" cy="822960"/>
+            <a:off x="11064240" y="182880"/>
+            <a:ext cx="822960" cy="457200"/>
           </a:xfrm>
           <a:prstGeom prst="rect">
             <a:avLst/>
@@ -5237,7 +5237,7 @@
       </p:sp>
       <p:pic>
         <p:nvPicPr>
-          <p:cNvPr id="3" name="Picture 2" descr="logo.png"/>
+          <p:cNvPr id="3" name="Picture 2" descr="image.png"/>
           <p:cNvPicPr>
             <a:picLocks noChangeAspect="1"/>
           </p:cNvPicPr>
@@ -5251,8 +5251,8 @@
         </p:blipFill>
         <p:spPr>
           <a:xfrm>
-            <a:off x="10789920" y="320040"/>
-            <a:ext cx="822960" cy="822960"/>
+            <a:off x="11064240" y="182880"/>
+            <a:ext cx="822960" cy="457200"/>
           </a:xfrm>
           <a:prstGeom prst="rect">
             <a:avLst/>

</xml_diff>